<commit_message>
CORR : Docs "keff" to "resp"
</commit_message>
<xml_diff>
--- a/docs/images/Image_maker.pptx
+++ b/docs/images/Image_maker.pptx
@@ -267,7 +267,7 @@
           <a:p>
             <a:fld id="{E382C574-8341-433E-8278-D812E3904DB0}" type="datetimeFigureOut">
               <a:rPr lang="fr-FR" smtClean="0"/>
-              <a:t>16/02/2026</a:t>
+              <a:t>30/06/2026</a:t>
             </a:fld>
             <a:endParaRPr lang="fr-FR"/>
           </a:p>
@@ -467,7 +467,7 @@
           <a:p>
             <a:fld id="{E382C574-8341-433E-8278-D812E3904DB0}" type="datetimeFigureOut">
               <a:rPr lang="fr-FR" smtClean="0"/>
-              <a:t>16/02/2026</a:t>
+              <a:t>30/06/2026</a:t>
             </a:fld>
             <a:endParaRPr lang="fr-FR"/>
           </a:p>
@@ -677,7 +677,7 @@
           <a:p>
             <a:fld id="{E382C574-8341-433E-8278-D812E3904DB0}" type="datetimeFigureOut">
               <a:rPr lang="fr-FR" smtClean="0"/>
-              <a:t>16/02/2026</a:t>
+              <a:t>30/06/2026</a:t>
             </a:fld>
             <a:endParaRPr lang="fr-FR"/>
           </a:p>
@@ -877,7 +877,7 @@
           <a:p>
             <a:fld id="{E382C574-8341-433E-8278-D812E3904DB0}" type="datetimeFigureOut">
               <a:rPr lang="fr-FR" smtClean="0"/>
-              <a:t>16/02/2026</a:t>
+              <a:t>30/06/2026</a:t>
             </a:fld>
             <a:endParaRPr lang="fr-FR"/>
           </a:p>
@@ -1153,7 +1153,7 @@
           <a:p>
             <a:fld id="{E382C574-8341-433E-8278-D812E3904DB0}" type="datetimeFigureOut">
               <a:rPr lang="fr-FR" smtClean="0"/>
-              <a:t>16/02/2026</a:t>
+              <a:t>30/06/2026</a:t>
             </a:fld>
             <a:endParaRPr lang="fr-FR"/>
           </a:p>
@@ -1421,7 +1421,7 @@
           <a:p>
             <a:fld id="{E382C574-8341-433E-8278-D812E3904DB0}" type="datetimeFigureOut">
               <a:rPr lang="fr-FR" smtClean="0"/>
-              <a:t>16/02/2026</a:t>
+              <a:t>30/06/2026</a:t>
             </a:fld>
             <a:endParaRPr lang="fr-FR"/>
           </a:p>
@@ -1836,7 +1836,7 @@
           <a:p>
             <a:fld id="{E382C574-8341-433E-8278-D812E3904DB0}" type="datetimeFigureOut">
               <a:rPr lang="fr-FR" smtClean="0"/>
-              <a:t>16/02/2026</a:t>
+              <a:t>30/06/2026</a:t>
             </a:fld>
             <a:endParaRPr lang="fr-FR"/>
           </a:p>
@@ -1978,7 +1978,7 @@
           <a:p>
             <a:fld id="{E382C574-8341-433E-8278-D812E3904DB0}" type="datetimeFigureOut">
               <a:rPr lang="fr-FR" smtClean="0"/>
-              <a:t>16/02/2026</a:t>
+              <a:t>30/06/2026</a:t>
             </a:fld>
             <a:endParaRPr lang="fr-FR"/>
           </a:p>
@@ -2091,7 +2091,7 @@
           <a:p>
             <a:fld id="{E382C574-8341-433E-8278-D812E3904DB0}" type="datetimeFigureOut">
               <a:rPr lang="fr-FR" smtClean="0"/>
-              <a:t>16/02/2026</a:t>
+              <a:t>30/06/2026</a:t>
             </a:fld>
             <a:endParaRPr lang="fr-FR"/>
           </a:p>
@@ -2404,7 +2404,7 @@
           <a:p>
             <a:fld id="{E382C574-8341-433E-8278-D812E3904DB0}" type="datetimeFigureOut">
               <a:rPr lang="fr-FR" smtClean="0"/>
-              <a:t>16/02/2026</a:t>
+              <a:t>30/06/2026</a:t>
             </a:fld>
             <a:endParaRPr lang="fr-FR"/>
           </a:p>
@@ -2693,7 +2693,7 @@
           <a:p>
             <a:fld id="{E382C574-8341-433E-8278-D812E3904DB0}" type="datetimeFigureOut">
               <a:rPr lang="fr-FR" smtClean="0"/>
-              <a:t>16/02/2026</a:t>
+              <a:t>30/06/2026</a:t>
             </a:fld>
             <a:endParaRPr lang="fr-FR"/>
           </a:p>
@@ -2936,7 +2936,7 @@
           <a:p>
             <a:fld id="{E382C574-8341-433E-8278-D812E3904DB0}" type="datetimeFigureOut">
               <a:rPr lang="fr-FR" smtClean="0"/>
-              <a:t>16/02/2026</a:t>
+              <a:t>30/06/2026</a:t>
             </a:fld>
             <a:endParaRPr lang="fr-FR"/>
           </a:p>
@@ -5605,8 +5605,8 @@
           </p:sp>
         </mc:Fallback>
       </mc:AlternateContent>
-      <mc:AlternateContent xmlns:mc="http://schemas.openxmlformats.org/markup-compatibility/2006" xmlns:a14="http://schemas.microsoft.com/office/drawing/2010/main">
-        <mc:Choice Requires="a14">
+      <mc:AlternateContent xmlns:mc="http://schemas.openxmlformats.org/markup-compatibility/2006">
+        <mc:Choice xmlns:a14="http://schemas.microsoft.com/office/drawing/2010/main" Requires="a14">
           <p:sp>
             <p:nvSpPr>
               <p:cNvPr id="21" name="TextBox 20">
@@ -5743,40 +5743,15 @@
                           </a:rPr>
                           <m:t>∆</m:t>
                         </m:r>
-                        <m:sSub>
-                          <m:sSubPr>
-                            <m:ctrlPr>
-                              <a:rPr lang="fr-FR" sz="1800" i="1" kern="100">
-                                <a:effectLst/>
-                                <a:latin typeface="Cambria Math" panose="02040503050406030204" pitchFamily="18" charset="0"/>
-                                <a:ea typeface="Times New Roman" panose="02020603050405020304" pitchFamily="18" charset="0"/>
-                                <a:cs typeface="Times New Roman" panose="02020603050405020304" pitchFamily="18" charset="0"/>
-                              </a:rPr>
-                            </m:ctrlPr>
-                          </m:sSubPr>
-                          <m:e>
-                            <m:r>
-                              <a:rPr lang="fr-FR" sz="1800" i="1" kern="100">
-                                <a:effectLst/>
-                                <a:latin typeface="Cambria Math" panose="02040503050406030204" pitchFamily="18" charset="0"/>
-                                <a:ea typeface="Times New Roman" panose="02020603050405020304" pitchFamily="18" charset="0"/>
-                                <a:cs typeface="Times New Roman" panose="02020603050405020304" pitchFamily="18" charset="0"/>
-                              </a:rPr>
-                              <m:t>𝑘</m:t>
-                            </m:r>
-                          </m:e>
-                          <m:sub>
-                            <m:r>
-                              <a:rPr lang="fr-FR" sz="1800" i="1" kern="100">
-                                <a:effectLst/>
-                                <a:latin typeface="Cambria Math" panose="02040503050406030204" pitchFamily="18" charset="0"/>
-                                <a:ea typeface="Times New Roman" panose="02020603050405020304" pitchFamily="18" charset="0"/>
-                                <a:cs typeface="Times New Roman" panose="02020603050405020304" pitchFamily="18" charset="0"/>
-                              </a:rPr>
-                              <m:t>𝑒𝑓𝑓</m:t>
-                            </m:r>
-                          </m:sub>
-                        </m:sSub>
+                        <m:r>
+                          <a:rPr lang="fr-FR" sz="1800" b="0" i="1" kern="100" smtClean="0">
+                            <a:effectLst/>
+                            <a:latin typeface="Cambria Math" panose="02040503050406030204" pitchFamily="18" charset="0"/>
+                            <a:ea typeface="Times New Roman" panose="02020603050405020304" pitchFamily="18" charset="0"/>
+                            <a:cs typeface="Times New Roman" panose="02020603050405020304" pitchFamily="18" charset="0"/>
+                          </a:rPr>
+                          <m:t>𝑟𝑒𝑠𝑝</m:t>
+                        </m:r>
                       </m:num>
                       <m:den>
                         <m:r>
@@ -5842,16 +5817,15 @@
                     <a:ea typeface="Cambria" panose="02040503050406030204" pitchFamily="18" charset="0"/>
                     <a:cs typeface="Times New Roman" panose="02020603050405020304" pitchFamily="18" charset="0"/>
                   </a:rPr>
-                  <a:t>: variation of k</a:t>
+                  <a:t>: variation of </a:t>
                 </a:r>
                 <a:r>
-                  <a:rPr lang="fr-FR" sz="1800" i="1" kern="100" baseline="-25000" dirty="0">
-                    <a:effectLst/>
+                  <a:rPr lang="fr-FR" i="1" kern="100" dirty="0" err="1">
                     <a:latin typeface="Cambria" panose="02040503050406030204" pitchFamily="18" charset="0"/>
                     <a:ea typeface="Cambria" panose="02040503050406030204" pitchFamily="18" charset="0"/>
                     <a:cs typeface="Times New Roman" panose="02020603050405020304" pitchFamily="18" charset="0"/>
                   </a:rPr>
-                  <a:t>eff</a:t>
+                  <a:t>response</a:t>
                 </a:r>
                 <a:r>
                   <a:rPr lang="fr-FR" sz="1800" i="1" kern="100" dirty="0">
@@ -5860,16 +5834,15 @@
                     <a:ea typeface="Cambria" panose="02040503050406030204" pitchFamily="18" charset="0"/>
                     <a:cs typeface="Times New Roman" panose="02020603050405020304" pitchFamily="18" charset="0"/>
                   </a:rPr>
-                  <a:t> (∆k</a:t>
+                  <a:t> (∆</a:t>
                 </a:r>
                 <a:r>
-                  <a:rPr lang="fr-FR" sz="1800" i="1" kern="100" baseline="-25000" dirty="0">
-                    <a:effectLst/>
+                  <a:rPr lang="fr-FR" i="1" kern="100" dirty="0" err="1">
                     <a:latin typeface="Cambria" panose="02040503050406030204" pitchFamily="18" charset="0"/>
                     <a:ea typeface="Cambria" panose="02040503050406030204" pitchFamily="18" charset="0"/>
                     <a:cs typeface="Times New Roman" panose="02020603050405020304" pitchFamily="18" charset="0"/>
                   </a:rPr>
-                  <a:t>eff</a:t>
+                  <a:t>resp</a:t>
                 </a:r>
                 <a:r>
                   <a:rPr lang="fr-FR" sz="1800" i="1" kern="100" dirty="0">
@@ -6209,7 +6182,7 @@
             </p:txBody>
           </p:sp>
         </mc:Choice>
-        <mc:Fallback xmlns="">
+        <mc:Fallback>
           <p:sp>
             <p:nvSpPr>
               <p:cNvPr id="21" name="TextBox 20">
@@ -6235,7 +6208,7 @@
               <a:blipFill>
                 <a:blip r:embed="rId5"/>
                 <a:stretch>
-                  <a:fillRect r="-195" b="-3947"/>
+                  <a:fillRect r="-195" b="-2961"/>
                 </a:stretch>
               </a:blipFill>
               <a:ln w="12700">
@@ -6249,7 +6222,7 @@
               <a:lstStyle/>
               <a:p>
                 <a:r>
-                  <a:rPr lang="en-US">
+                  <a:rPr lang="fr-FR">
                     <a:noFill/>
                   </a:rPr>
                   <a:t> </a:t>
@@ -14864,8 +14837,8 @@
           </a:graphicData>
         </a:graphic>
       </p:graphicFrame>
-      <mc:AlternateContent xmlns:mc="http://schemas.openxmlformats.org/markup-compatibility/2006">
-        <mc:Choice xmlns:a14="http://schemas.microsoft.com/office/drawing/2010/main" Requires="a14">
+      <mc:AlternateContent xmlns:mc="http://schemas.openxmlformats.org/markup-compatibility/2006" xmlns:a14="http://schemas.microsoft.com/office/drawing/2010/main">
+        <mc:Choice Requires="a14">
           <p:sp>
             <p:nvSpPr>
               <p:cNvPr id="7" name="TextBox 6">
@@ -16356,7 +16329,7 @@
             </p:txBody>
           </p:sp>
         </mc:Choice>
-        <mc:Fallback>
+        <mc:Fallback xmlns="">
           <p:sp>
             <p:nvSpPr>
               <p:cNvPr id="7" name="TextBox 6">
@@ -21276,8 +21249,8 @@
           </a:p>
         </p:txBody>
       </p:sp>
-      <mc:AlternateContent xmlns:mc="http://schemas.openxmlformats.org/markup-compatibility/2006" xmlns:a14="http://schemas.microsoft.com/office/drawing/2010/main">
-        <mc:Choice Requires="a14">
+      <mc:AlternateContent xmlns:mc="http://schemas.openxmlformats.org/markup-compatibility/2006">
+        <mc:Choice xmlns:a14="http://schemas.microsoft.com/office/drawing/2010/main" Requires="a14">
           <p:sp>
             <p:nvSpPr>
               <p:cNvPr id="21" name="TextBox 20">
@@ -21293,7 +21266,7 @@
             <p:spPr>
               <a:xfrm>
                 <a:off x="2726106" y="3121347"/>
-                <a:ext cx="6096000" cy="1412759"/>
+                <a:ext cx="6096000" cy="1275542"/>
               </a:xfrm>
               <a:prstGeom prst="rect">
                 <a:avLst/>
@@ -21351,31 +21324,12 @@
                         </m:ctrlPr>
                       </m:sSupPr>
                       <m:e>
-                        <m:sSub>
-                          <m:sSubPr>
-                            <m:ctrlPr>
-                              <a:rPr lang="fr-FR" i="1">
-                                <a:latin typeface="Cambria Math" panose="02040503050406030204" pitchFamily="18" charset="0"/>
-                              </a:rPr>
-                            </m:ctrlPr>
-                          </m:sSubPr>
-                          <m:e>
-                            <m:r>
-                              <a:rPr lang="fr-FR" i="1">
-                                <a:latin typeface="Cambria Math" panose="02040503050406030204" pitchFamily="18" charset="0"/>
-                              </a:rPr>
-                              <m:t>𝑘</m:t>
-                            </m:r>
-                          </m:e>
-                          <m:sub>
-                            <m:r>
-                              <a:rPr lang="fr-FR" i="1">
-                                <a:latin typeface="Cambria Math" panose="02040503050406030204" pitchFamily="18" charset="0"/>
-                              </a:rPr>
-                              <m:t>𝑒𝑓𝑓</m:t>
-                            </m:r>
-                          </m:sub>
-                        </m:sSub>
+                        <m:r>
+                          <a:rPr lang="fr-FR" b="0" i="1" smtClean="0">
+                            <a:latin typeface="Cambria Math" panose="02040503050406030204" pitchFamily="18" charset="0"/>
+                          </a:rPr>
+                          <m:t>𝑟𝑒𝑠𝑝</m:t>
+                        </m:r>
                       </m:e>
                       <m:sup>
                         <m:r>
@@ -21406,8 +21360,8 @@
                         </m:ctrlPr>
                       </m:fPr>
                       <m:num>
-                        <m:sSubSup>
-                          <m:sSubSupPr>
+                        <m:sSup>
+                          <m:sSupPr>
                             <m:ctrlPr>
                               <a:rPr lang="fr-FR" sz="1800" i="1" kern="100" smtClean="0">
                                 <a:effectLst/>
@@ -21415,7 +21369,7 @@
                                 <a:cs typeface="Times New Roman" panose="02020603050405020304" pitchFamily="18" charset="0"/>
                               </a:rPr>
                             </m:ctrlPr>
-                          </m:sSubSupPr>
+                          </m:sSupPr>
                           <m:e>
                             <m:r>
                               <a:rPr lang="fr-FR" sz="1800" b="0" i="1" kern="100" smtClean="0">
@@ -21423,19 +21377,9 @@
                                 <a:latin typeface="Cambria Math" panose="02040503050406030204" pitchFamily="18" charset="0"/>
                                 <a:cs typeface="Times New Roman" panose="02020603050405020304" pitchFamily="18" charset="0"/>
                               </a:rPr>
-                              <m:t>𝑘</m:t>
+                              <m:t>𝑟𝑒𝑠𝑝</m:t>
                             </m:r>
                           </m:e>
-                          <m:sub>
-                            <m:r>
-                              <a:rPr lang="fr-FR" sz="1800" b="0" i="1" kern="100" smtClean="0">
-                                <a:effectLst/>
-                                <a:latin typeface="Cambria Math" panose="02040503050406030204" pitchFamily="18" charset="0"/>
-                                <a:cs typeface="Times New Roman" panose="02020603050405020304" pitchFamily="18" charset="0"/>
-                              </a:rPr>
-                              <m:t>𝑒𝑓𝑓</m:t>
-                            </m:r>
-                          </m:sub>
                           <m:sup>
                             <m:r>
                               <a:rPr lang="fr-FR" sz="1800" b="0" i="1" kern="100" smtClean="0">
@@ -21446,7 +21390,7 @@
                               <m:t>𝑐𝑎𝑙𝑐</m:t>
                             </m:r>
                           </m:sup>
-                        </m:sSubSup>
+                        </m:sSup>
                         <m:r>
                           <a:rPr lang="fr-FR" sz="1800" b="0" i="1" kern="100" smtClean="0">
                             <a:effectLst/>
@@ -21455,33 +21399,24 @@
                           </a:rPr>
                           <m:t>−</m:t>
                         </m:r>
-                        <m:sSubSup>
-                          <m:sSubSupPr>
+                        <m:sSup>
+                          <m:sSupPr>
                             <m:ctrlPr>
                               <a:rPr lang="fr-FR" i="1" kern="100">
                                 <a:latin typeface="Cambria Math" panose="02040503050406030204" pitchFamily="18" charset="0"/>
                                 <a:cs typeface="Times New Roman" panose="02020603050405020304" pitchFamily="18" charset="0"/>
                               </a:rPr>
                             </m:ctrlPr>
-                          </m:sSubSupPr>
+                          </m:sSupPr>
                           <m:e>
                             <m:r>
                               <a:rPr lang="fr-FR" i="1" kern="100">
                                 <a:latin typeface="Cambria Math" panose="02040503050406030204" pitchFamily="18" charset="0"/>
                                 <a:cs typeface="Times New Roman" panose="02020603050405020304" pitchFamily="18" charset="0"/>
                               </a:rPr>
-                              <m:t>𝑘</m:t>
+                              <m:t>𝑟𝑒𝑠𝑝</m:t>
                             </m:r>
                           </m:e>
-                          <m:sub>
-                            <m:r>
-                              <a:rPr lang="fr-FR" i="1" kern="100">
-                                <a:latin typeface="Cambria Math" panose="02040503050406030204" pitchFamily="18" charset="0"/>
-                                <a:cs typeface="Times New Roman" panose="02020603050405020304" pitchFamily="18" charset="0"/>
-                              </a:rPr>
-                              <m:t>𝑒𝑓𝑓</m:t>
-                            </m:r>
-                          </m:sub>
                           <m:sup>
                             <m:r>
                               <a:rPr lang="fr-FR" b="0" i="1" kern="100" smtClean="0">
@@ -21491,46 +21426,37 @@
                               <m:t>𝑒𝑥𝑝</m:t>
                             </m:r>
                           </m:sup>
-                        </m:sSubSup>
+                        </m:sSup>
                       </m:num>
                       <m:den>
-                        <m:sSubSup>
-                          <m:sSubSupPr>
+                        <m:sSup>
+                          <m:sSupPr>
                             <m:ctrlPr>
                               <a:rPr lang="fr-FR" i="1" kern="100">
                                 <a:latin typeface="Cambria Math" panose="02040503050406030204" pitchFamily="18" charset="0"/>
                                 <a:cs typeface="Times New Roman" panose="02020603050405020304" pitchFamily="18" charset="0"/>
                               </a:rPr>
                             </m:ctrlPr>
-                          </m:sSubSupPr>
+                          </m:sSupPr>
                           <m:e>
                             <m:r>
                               <a:rPr lang="fr-FR" i="1" kern="100">
                                 <a:latin typeface="Cambria Math" panose="02040503050406030204" pitchFamily="18" charset="0"/>
                                 <a:cs typeface="Times New Roman" panose="02020603050405020304" pitchFamily="18" charset="0"/>
                               </a:rPr>
-                              <m:t>𝑘</m:t>
+                              <m:t>𝑟𝑒𝑠𝑝</m:t>
                             </m:r>
                           </m:e>
-                          <m:sub>
+                          <m:sup>
                             <m:r>
                               <a:rPr lang="fr-FR" i="1" kern="100">
-                                <a:latin typeface="Cambria Math" panose="02040503050406030204" pitchFamily="18" charset="0"/>
-                                <a:cs typeface="Times New Roman" panose="02020603050405020304" pitchFamily="18" charset="0"/>
-                              </a:rPr>
-                              <m:t>𝑒𝑓𝑓</m:t>
-                            </m:r>
-                          </m:sub>
-                          <m:sup>
-                            <m:r>
-                              <a:rPr lang="fr-FR" b="0" i="1" kern="100" smtClean="0">
                                 <a:latin typeface="Cambria Math" panose="02040503050406030204" pitchFamily="18" charset="0"/>
                                 <a:cs typeface="Times New Roman" panose="02020603050405020304" pitchFamily="18" charset="0"/>
                               </a:rPr>
                               <m:t>𝑐𝑎𝑙𝑐</m:t>
                             </m:r>
                           </m:sup>
-                        </m:sSubSup>
+                        </m:sSup>
                       </m:den>
                     </m:f>
                   </m:oMath>
@@ -21628,15 +21554,15 @@
                     <a:ea typeface="Cambria" panose="02040503050406030204" pitchFamily="18" charset="0"/>
                     <a:cs typeface="Times New Roman" panose="02020603050405020304" pitchFamily="18" charset="0"/>
                   </a:rPr>
-                  <a:t> k</a:t>
+                  <a:t> </a:t>
                 </a:r>
                 <a:r>
-                  <a:rPr lang="fr-FR" i="1" kern="100" baseline="-25000" dirty="0">
+                  <a:rPr lang="fr-FR" i="1" kern="100" dirty="0" err="1">
                     <a:latin typeface="Cambria" panose="02040503050406030204" pitchFamily="18" charset="0"/>
                     <a:ea typeface="Cambria" panose="02040503050406030204" pitchFamily="18" charset="0"/>
                     <a:cs typeface="Times New Roman" panose="02020603050405020304" pitchFamily="18" charset="0"/>
                   </a:rPr>
-                  <a:t>eff</a:t>
+                  <a:t>response</a:t>
                 </a:r>
                 <a:r>
                   <a:rPr lang="fr-FR" i="1" kern="100" dirty="0">
@@ -21746,7 +21672,7 @@
             </p:txBody>
           </p:sp>
         </mc:Choice>
-        <mc:Fallback xmlns="">
+        <mc:Fallback>
           <p:sp>
             <p:nvSpPr>
               <p:cNvPr id="21" name="TextBox 20">
@@ -21764,7 +21690,7 @@
             <p:spPr>
               <a:xfrm>
                 <a:off x="2726106" y="3121347"/>
-                <a:ext cx="6096000" cy="1412759"/>
+                <a:ext cx="6096000" cy="1275542"/>
               </a:xfrm>
               <a:prstGeom prst="rect">
                 <a:avLst/>
@@ -21772,7 +21698,7 @@
               <a:blipFill>
                 <a:blip r:embed="rId2"/>
                 <a:stretch>
-                  <a:fillRect b="-4274"/>
+                  <a:fillRect b="-6161"/>
                 </a:stretch>
               </a:blipFill>
               <a:ln w="12700">
@@ -21786,7 +21712,7 @@
               <a:lstStyle/>
               <a:p>
                 <a:r>
-                  <a:rPr lang="en-US">
+                  <a:rPr lang="fr-FR">
                     <a:noFill/>
                   </a:rPr>
                   <a:t> </a:t>
@@ -21945,8 +21871,8 @@
           </p:sp>
         </mc:Fallback>
       </mc:AlternateContent>
-      <mc:AlternateContent xmlns:mc="http://schemas.openxmlformats.org/markup-compatibility/2006" xmlns:a14="http://schemas.microsoft.com/office/drawing/2010/main">
-        <mc:Choice Requires="a14">
+      <mc:AlternateContent xmlns:mc="http://schemas.openxmlformats.org/markup-compatibility/2006">
+        <mc:Choice xmlns:a14="http://schemas.microsoft.com/office/drawing/2010/main" Requires="a14">
           <p:graphicFrame>
             <p:nvGraphicFramePr>
               <p:cNvPr id="4" name="Tableau 3">
@@ -21962,7 +21888,7 @@
               <p:nvPr>
                 <p:extLst>
                   <p:ext uri="{D42A27DB-BD31-4B8C-83A1-F6EECF244321}">
-                    <p14:modId xmlns:p14="http://schemas.microsoft.com/office/powerpoint/2010/main" val="1078891413"/>
+                    <p14:modId xmlns:p14="http://schemas.microsoft.com/office/powerpoint/2010/main" val="2726715427"/>
                   </p:ext>
                 </p:extLst>
               </p:nvPr>
@@ -22116,31 +22042,12 @@
                                     </m:ctrlPr>
                                   </m:sSupPr>
                                   <m:e>
-                                    <m:sSub>
-                                      <m:sSubPr>
-                                        <m:ctrlPr>
-                                          <a:rPr lang="fr-FR" b="0" i="1" smtClean="0">
-                                            <a:latin typeface="Cambria Math" panose="02040503050406030204" pitchFamily="18" charset="0"/>
-                                          </a:rPr>
-                                        </m:ctrlPr>
-                                      </m:sSubPr>
-                                      <m:e>
-                                        <m:r>
-                                          <a:rPr lang="fr-FR" b="0" i="1" smtClean="0">
-                                            <a:latin typeface="Cambria Math" panose="02040503050406030204" pitchFamily="18" charset="0"/>
-                                          </a:rPr>
-                                          <m:t>𝑘</m:t>
-                                        </m:r>
-                                      </m:e>
-                                      <m:sub>
-                                        <m:r>
-                                          <a:rPr lang="fr-FR" b="0" i="1" smtClean="0">
-                                            <a:latin typeface="Cambria Math" panose="02040503050406030204" pitchFamily="18" charset="0"/>
-                                          </a:rPr>
-                                          <m:t>𝑒𝑓𝑓</m:t>
-                                        </m:r>
-                                      </m:sub>
-                                    </m:sSub>
+                                    <m:r>
+                                      <a:rPr lang="fr-FR" b="0" i="1" smtClean="0">
+                                        <a:latin typeface="Cambria Math" panose="02040503050406030204" pitchFamily="18" charset="0"/>
+                                      </a:rPr>
+                                      <m:t>𝑟𝑒𝑠𝑝</m:t>
+                                    </m:r>
                                   </m:e>
                                   <m:sup>
                                     <m:r>
@@ -22247,31 +22154,12 @@
                                     </m:ctrlPr>
                                   </m:sSupPr>
                                   <m:e>
-                                    <m:sSub>
-                                      <m:sSubPr>
-                                        <m:ctrlPr>
-                                          <a:rPr lang="fr-FR" b="0" i="1" smtClean="0">
-                                            <a:latin typeface="Cambria Math" panose="02040503050406030204" pitchFamily="18" charset="0"/>
-                                          </a:rPr>
-                                        </m:ctrlPr>
-                                      </m:sSubPr>
-                                      <m:e>
-                                        <m:r>
-                                          <a:rPr lang="fr-FR" b="0" i="1" smtClean="0">
-                                            <a:latin typeface="Cambria Math" panose="02040503050406030204" pitchFamily="18" charset="0"/>
-                                          </a:rPr>
-                                          <m:t>𝑘</m:t>
-                                        </m:r>
-                                      </m:e>
-                                      <m:sub>
-                                        <m:r>
-                                          <a:rPr lang="fr-FR" b="0" i="1" smtClean="0">
-                                            <a:latin typeface="Cambria Math" panose="02040503050406030204" pitchFamily="18" charset="0"/>
-                                          </a:rPr>
-                                          <m:t>𝑒𝑓𝑓</m:t>
-                                        </m:r>
-                                      </m:sub>
-                                    </m:sSub>
+                                    <m:r>
+                                      <a:rPr lang="fr-FR" b="0" i="1" smtClean="0">
+                                        <a:latin typeface="Cambria Math" panose="02040503050406030204" pitchFamily="18" charset="0"/>
+                                      </a:rPr>
+                                      <m:t>𝑟𝑒𝑠𝑝</m:t>
+                                    </m:r>
                                   </m:e>
                                   <m:sup>
                                     <m:r>
@@ -22386,31 +22274,12 @@
                                     </m:ctrlPr>
                                   </m:sSupPr>
                                   <m:e>
-                                    <m:sSub>
-                                      <m:sSubPr>
-                                        <m:ctrlPr>
-                                          <a:rPr lang="fr-FR" b="0" i="1" smtClean="0">
-                                            <a:latin typeface="Cambria Math" panose="02040503050406030204" pitchFamily="18" charset="0"/>
-                                          </a:rPr>
-                                        </m:ctrlPr>
-                                      </m:sSubPr>
-                                      <m:e>
-                                        <m:r>
-                                          <a:rPr lang="fr-FR" b="0" i="1" smtClean="0">
-                                            <a:latin typeface="Cambria Math" panose="02040503050406030204" pitchFamily="18" charset="0"/>
-                                          </a:rPr>
-                                          <m:t>𝑘</m:t>
-                                        </m:r>
-                                      </m:e>
-                                      <m:sub>
-                                        <m:r>
-                                          <a:rPr lang="fr-FR" b="0" i="1" smtClean="0">
-                                            <a:latin typeface="Cambria Math" panose="02040503050406030204" pitchFamily="18" charset="0"/>
-                                          </a:rPr>
-                                          <m:t>𝑒𝑓𝑓</m:t>
-                                        </m:r>
-                                      </m:sub>
-                                    </m:sSub>
+                                    <m:r>
+                                      <a:rPr lang="fr-FR" b="0" i="1" smtClean="0">
+                                        <a:latin typeface="Cambria Math" panose="02040503050406030204" pitchFamily="18" charset="0"/>
+                                      </a:rPr>
+                                      <m:t>𝑟𝑒𝑠𝑝</m:t>
+                                    </m:r>
                                   </m:e>
                                   <m:sup>
                                     <m:r>
@@ -22542,7 +22411,7 @@
             </a:graphic>
           </p:graphicFrame>
         </mc:Choice>
-        <mc:Fallback xmlns="">
+        <mc:Fallback>
           <p:graphicFrame>
             <p:nvGraphicFramePr>
               <p:cNvPr id="4" name="Tableau 3">
@@ -22558,7 +22427,7 @@
               <p:nvPr>
                 <p:extLst>
                   <p:ext uri="{D42A27DB-BD31-4B8C-83A1-F6EECF244321}">
-                    <p14:modId xmlns:p14="http://schemas.microsoft.com/office/powerpoint/2010/main" val="1078891413"/>
+                    <p14:modId xmlns:p14="http://schemas.microsoft.com/office/powerpoint/2010/main" val="2726715427"/>
                   </p:ext>
                 </p:extLst>
               </p:nvPr>
@@ -22925,8 +22794,8 @@
           <a:chExt cx="0" cy="0"/>
         </a:xfrm>
       </p:grpSpPr>
-      <mc:AlternateContent xmlns:mc="http://schemas.openxmlformats.org/markup-compatibility/2006" xmlns:a14="http://schemas.microsoft.com/office/drawing/2010/main">
-        <mc:Choice Requires="a14">
+      <mc:AlternateContent xmlns:mc="http://schemas.openxmlformats.org/markup-compatibility/2006">
+        <mc:Choice xmlns:a14="http://schemas.microsoft.com/office/drawing/2010/main" Requires="a14">
           <p:graphicFrame>
             <p:nvGraphicFramePr>
               <p:cNvPr id="4" name="Table 3">
@@ -22942,7 +22811,7 @@
               <p:nvPr>
                 <p:extLst>
                   <p:ext uri="{D42A27DB-BD31-4B8C-83A1-F6EECF244321}">
-                    <p14:modId xmlns:p14="http://schemas.microsoft.com/office/powerpoint/2010/main" val="2146074914"/>
+                    <p14:modId xmlns:p14="http://schemas.microsoft.com/office/powerpoint/2010/main" val="2741742299"/>
                   </p:ext>
                 </p:extLst>
               </p:nvPr>
@@ -23443,7 +23312,7 @@
                                                 <a:ea typeface="Cambria" panose="02040503050406030204" pitchFamily="18" charset="0"/>
                                                 <a:cs typeface="Times New Roman" panose="02020603050405020304" pitchFamily="18" charset="0"/>
                                               </a:rPr>
-                                              <m:t>𝑘𝑒𝑓𝑓</m:t>
+                                              <m:t>𝑟𝑒𝑠𝑝</m:t>
                                             </m:r>
                                           </m:e>
                                           <m:sub>
@@ -23967,7 +23836,7 @@
                                                 <a:ea typeface="Cambria" panose="02040503050406030204" pitchFamily="18" charset="0"/>
                                                 <a:cs typeface="Times New Roman" panose="02020603050405020304" pitchFamily="18" charset="0"/>
                                               </a:rPr>
-                                              <m:t>𝑘𝑒𝑓𝑓</m:t>
+                                              <m:t>𝑟𝑒𝑠𝑝</m:t>
                                             </m:r>
                                           </m:e>
                                           <m:sub>
@@ -24431,7 +24300,7 @@
             </a:graphic>
           </p:graphicFrame>
         </mc:Choice>
-        <mc:Fallback xmlns="">
+        <mc:Fallback>
           <p:graphicFrame>
             <p:nvGraphicFramePr>
               <p:cNvPr id="4" name="Table 3">
@@ -24447,7 +24316,7 @@
               <p:nvPr>
                 <p:extLst>
                   <p:ext uri="{D42A27DB-BD31-4B8C-83A1-F6EECF244321}">
-                    <p14:modId xmlns:p14="http://schemas.microsoft.com/office/powerpoint/2010/main" val="2146074914"/>
+                    <p14:modId xmlns:p14="http://schemas.microsoft.com/office/powerpoint/2010/main" val="2741742299"/>
                   </p:ext>
                 </p:extLst>
               </p:nvPr>
@@ -25726,12 +25595,20 @@
               <a:buChar char="•"/>
             </a:pPr>
             <a:r>
+              <a:rPr lang="fr-FR" i="1" kern="100" dirty="0" err="1">
+                <a:latin typeface="Cambria" panose="02040503050406030204" pitchFamily="18" charset="0"/>
+                <a:ea typeface="Cambria" panose="02040503050406030204" pitchFamily="18" charset="0"/>
+                <a:cs typeface="Times New Roman" panose="02020603050405020304" pitchFamily="18" charset="0"/>
+              </a:rPr>
+              <a:t>Symetric</a:t>
+            </a:r>
+            <a:r>
               <a:rPr lang="fr-FR" i="1" kern="100" dirty="0">
                 <a:latin typeface="Cambria" panose="02040503050406030204" pitchFamily="18" charset="0"/>
                 <a:ea typeface="Cambria" panose="02040503050406030204" pitchFamily="18" charset="0"/>
                 <a:cs typeface="Times New Roman" panose="02020603050405020304" pitchFamily="18" charset="0"/>
               </a:rPr>
-              <a:t>Diagonal matrix</a:t>
+              <a:t> matrix</a:t>
             </a:r>
           </a:p>
           <a:p>
@@ -25794,8 +25671,8 @@
           </a:p>
         </p:txBody>
       </p:sp>
-      <mc:AlternateContent xmlns:mc="http://schemas.openxmlformats.org/markup-compatibility/2006" xmlns:a14="http://schemas.microsoft.com/office/drawing/2010/main">
-        <mc:Choice Requires="a14">
+      <mc:AlternateContent xmlns:mc="http://schemas.openxmlformats.org/markup-compatibility/2006">
+        <mc:Choice xmlns:a14="http://schemas.microsoft.com/office/drawing/2010/main" Requires="a14">
           <p:sp>
             <p:nvSpPr>
               <p:cNvPr id="9" name="TextBox 6">
@@ -25810,8 +25687,8 @@
             </p:nvSpPr>
             <p:spPr>
               <a:xfrm>
-                <a:off x="444689" y="4741354"/>
-                <a:ext cx="11302621" cy="1569721"/>
+                <a:off x="444689" y="4699677"/>
+                <a:ext cx="11302621" cy="2067516"/>
               </a:xfrm>
               <a:prstGeom prst="roundRect">
                 <a:avLst/>
@@ -25850,7 +25727,236 @@
                     <a:ea typeface="Cambria" panose="02040503050406030204" pitchFamily="18" charset="0"/>
                     <a:cs typeface="Times New Roman" panose="02020603050405020304" pitchFamily="18" charset="0"/>
                   </a:rPr>
-                  <a:t>The theory described in the SCALE 6.3.1 user manual (Section 6.8.4.2) indicates the presence of a diagonal (“E/C”) matrix on both sides of the experimental uncertainty matrix, thereby transforming its terms into experimental uncertainties relative to the calculated keff</a:t>
+                  <a:t>This matrix can incorporate the correlation factors between experiments, making the non-diagonal elements equal to : </a:t>
+                </a:r>
+                <a14:m>
+                  <m:oMath xmlns:m="http://schemas.openxmlformats.org/officeDocument/2006/math">
+                    <m:f>
+                      <m:fPr>
+                        <m:ctrlPr>
+                          <a:rPr lang="fr-FR" sz="1400" i="1">
+                            <a:latin typeface="Cambria Math" panose="02040503050406030204" pitchFamily="18" charset="0"/>
+                            <a:ea typeface="Cambria" panose="02040503050406030204" pitchFamily="18" charset="0"/>
+                            <a:cs typeface="Times New Roman" panose="02020603050405020304" pitchFamily="18" charset="0"/>
+                          </a:rPr>
+                        </m:ctrlPr>
+                      </m:fPr>
+                      <m:num>
+                        <m:sSubSup>
+                          <m:sSubSupPr>
+                            <m:ctrlPr>
+                              <a:rPr lang="fr-FR" sz="1400" i="1" smtClean="0">
+                                <a:latin typeface="Cambria Math" panose="02040503050406030204" pitchFamily="18" charset="0"/>
+                                <a:ea typeface="Cambria" panose="02040503050406030204" pitchFamily="18" charset="0"/>
+                                <a:cs typeface="Times New Roman" panose="02020603050405020304" pitchFamily="18" charset="0"/>
+                              </a:rPr>
+                            </m:ctrlPr>
+                          </m:sSubSupPr>
+                          <m:e>
+                            <m:r>
+                              <a:rPr lang="fr-FR" sz="1400" i="1" smtClean="0">
+                                <a:latin typeface="Cambria Math" panose="02040503050406030204" pitchFamily="18" charset="0"/>
+                                <a:ea typeface="Cambria Math" panose="02040503050406030204" pitchFamily="18" charset="0"/>
+                                <a:cs typeface="Times New Roman" panose="02020603050405020304" pitchFamily="18" charset="0"/>
+                              </a:rPr>
+                              <m:t>𝜎</m:t>
+                            </m:r>
+                          </m:e>
+                          <m:sub>
+                            <m:r>
+                              <a:rPr lang="fr-FR" sz="1400" b="0" i="1" smtClean="0">
+                                <a:latin typeface="Cambria Math" panose="02040503050406030204" pitchFamily="18" charset="0"/>
+                                <a:ea typeface="Cambria" panose="02040503050406030204" pitchFamily="18" charset="0"/>
+                                <a:cs typeface="Times New Roman" panose="02020603050405020304" pitchFamily="18" charset="0"/>
+                              </a:rPr>
+                              <m:t>𝑒𝑥𝑝</m:t>
+                            </m:r>
+                          </m:sub>
+                          <m:sup>
+                            <m:r>
+                              <a:rPr lang="fr-FR" sz="1400" b="0" i="1" smtClean="0">
+                                <a:latin typeface="Cambria Math" panose="02040503050406030204" pitchFamily="18" charset="0"/>
+                                <a:ea typeface="Cambria" panose="02040503050406030204" pitchFamily="18" charset="0"/>
+                                <a:cs typeface="Times New Roman" panose="02020603050405020304" pitchFamily="18" charset="0"/>
+                              </a:rPr>
+                              <m:t>𝑗</m:t>
+                            </m:r>
+                          </m:sup>
+                        </m:sSubSup>
+                      </m:num>
+                      <m:den>
+                        <m:sSubSup>
+                          <m:sSubSupPr>
+                            <m:ctrlPr>
+                              <a:rPr lang="fr-FR" sz="1400" i="1">
+                                <a:latin typeface="Cambria Math" panose="02040503050406030204" pitchFamily="18" charset="0"/>
+                                <a:ea typeface="Cambria" panose="02040503050406030204" pitchFamily="18" charset="0"/>
+                                <a:cs typeface="Times New Roman" panose="02020603050405020304" pitchFamily="18" charset="0"/>
+                              </a:rPr>
+                            </m:ctrlPr>
+                          </m:sSubSupPr>
+                          <m:e>
+                            <m:r>
+                              <a:rPr lang="fr-FR" sz="1400" b="0" i="1" smtClean="0">
+                                <a:latin typeface="Cambria Math" panose="02040503050406030204" pitchFamily="18" charset="0"/>
+                                <a:ea typeface="Cambria" panose="02040503050406030204" pitchFamily="18" charset="0"/>
+                                <a:cs typeface="Times New Roman" panose="02020603050405020304" pitchFamily="18" charset="0"/>
+                              </a:rPr>
+                              <m:t>𝑟𝑒𝑠𝑝</m:t>
+                            </m:r>
+                          </m:e>
+                          <m:sub>
+                            <m:r>
+                              <a:rPr lang="fr-FR" sz="1400" i="1">
+                                <a:latin typeface="Cambria Math" panose="02040503050406030204" pitchFamily="18" charset="0"/>
+                                <a:ea typeface="Cambria" panose="02040503050406030204" pitchFamily="18" charset="0"/>
+                                <a:cs typeface="Times New Roman" panose="02020603050405020304" pitchFamily="18" charset="0"/>
+                              </a:rPr>
+                              <m:t>𝑒𝑥𝑝</m:t>
+                            </m:r>
+                          </m:sub>
+                          <m:sup>
+                            <m:r>
+                              <a:rPr lang="fr-FR" sz="1400" i="1">
+                                <a:latin typeface="Cambria Math" panose="02040503050406030204" pitchFamily="18" charset="0"/>
+                                <a:ea typeface="Cambria" panose="02040503050406030204" pitchFamily="18" charset="0"/>
+                                <a:cs typeface="Times New Roman" panose="02020603050405020304" pitchFamily="18" charset="0"/>
+                              </a:rPr>
+                              <m:t>𝑗</m:t>
+                            </m:r>
+                          </m:sup>
+                        </m:sSubSup>
+                      </m:den>
+                    </m:f>
+                    <m:r>
+                      <a:rPr lang="fr-FR" sz="1400" i="1" smtClean="0">
+                        <a:latin typeface="Cambria Math" panose="02040503050406030204" pitchFamily="18" charset="0"/>
+                        <a:ea typeface="Cambria Math" panose="02040503050406030204" pitchFamily="18" charset="0"/>
+                        <a:cs typeface="Times New Roman" panose="02020603050405020304" pitchFamily="18" charset="0"/>
+                      </a:rPr>
+                      <m:t>×</m:t>
+                    </m:r>
+                    <m:f>
+                      <m:fPr>
+                        <m:ctrlPr>
+                          <a:rPr lang="fr-FR" sz="1400" i="1">
+                            <a:latin typeface="Cambria Math" panose="02040503050406030204" pitchFamily="18" charset="0"/>
+                            <a:ea typeface="Cambria" panose="02040503050406030204" pitchFamily="18" charset="0"/>
+                            <a:cs typeface="Times New Roman" panose="02020603050405020304" pitchFamily="18" charset="0"/>
+                          </a:rPr>
+                        </m:ctrlPr>
+                      </m:fPr>
+                      <m:num>
+                        <m:sSubSup>
+                          <m:sSubSupPr>
+                            <m:ctrlPr>
+                              <a:rPr lang="fr-FR" sz="1400" i="1">
+                                <a:latin typeface="Cambria Math" panose="02040503050406030204" pitchFamily="18" charset="0"/>
+                                <a:ea typeface="Cambria" panose="02040503050406030204" pitchFamily="18" charset="0"/>
+                                <a:cs typeface="Times New Roman" panose="02020603050405020304" pitchFamily="18" charset="0"/>
+                              </a:rPr>
+                            </m:ctrlPr>
+                          </m:sSubSupPr>
+                          <m:e>
+                            <m:r>
+                              <a:rPr lang="fr-FR" sz="1400" i="1">
+                                <a:latin typeface="Cambria Math" panose="02040503050406030204" pitchFamily="18" charset="0"/>
+                                <a:ea typeface="Cambria Math" panose="02040503050406030204" pitchFamily="18" charset="0"/>
+                                <a:cs typeface="Times New Roman" panose="02020603050405020304" pitchFamily="18" charset="0"/>
+                              </a:rPr>
+                              <m:t>𝜎</m:t>
+                            </m:r>
+                          </m:e>
+                          <m:sub>
+                            <m:r>
+                              <a:rPr lang="fr-FR" sz="1400" i="1">
+                                <a:latin typeface="Cambria Math" panose="02040503050406030204" pitchFamily="18" charset="0"/>
+                                <a:ea typeface="Cambria" panose="02040503050406030204" pitchFamily="18" charset="0"/>
+                                <a:cs typeface="Times New Roman" panose="02020603050405020304" pitchFamily="18" charset="0"/>
+                              </a:rPr>
+                              <m:t>𝑒𝑥𝑝</m:t>
+                            </m:r>
+                          </m:sub>
+                          <m:sup>
+                            <m:r>
+                              <a:rPr lang="fr-FR" sz="1400" b="0" i="1" smtClean="0">
+                                <a:latin typeface="Cambria Math" panose="02040503050406030204" pitchFamily="18" charset="0"/>
+                                <a:ea typeface="Cambria" panose="02040503050406030204" pitchFamily="18" charset="0"/>
+                                <a:cs typeface="Times New Roman" panose="02020603050405020304" pitchFamily="18" charset="0"/>
+                              </a:rPr>
+                              <m:t>𝑖</m:t>
+                            </m:r>
+                          </m:sup>
+                        </m:sSubSup>
+                      </m:num>
+                      <m:den>
+                        <m:sSubSup>
+                          <m:sSubSupPr>
+                            <m:ctrlPr>
+                              <a:rPr lang="fr-FR" sz="1400" i="1">
+                                <a:latin typeface="Cambria Math" panose="02040503050406030204" pitchFamily="18" charset="0"/>
+                                <a:ea typeface="Cambria" panose="02040503050406030204" pitchFamily="18" charset="0"/>
+                                <a:cs typeface="Times New Roman" panose="02020603050405020304" pitchFamily="18" charset="0"/>
+                              </a:rPr>
+                            </m:ctrlPr>
+                          </m:sSubSupPr>
+                          <m:e>
+                            <m:r>
+                              <a:rPr lang="fr-FR" sz="1400" i="1">
+                                <a:latin typeface="Cambria Math" panose="02040503050406030204" pitchFamily="18" charset="0"/>
+                                <a:ea typeface="Cambria" panose="02040503050406030204" pitchFamily="18" charset="0"/>
+                                <a:cs typeface="Times New Roman" panose="02020603050405020304" pitchFamily="18" charset="0"/>
+                              </a:rPr>
+                              <m:t>𝑟𝑒𝑠𝑝</m:t>
+                            </m:r>
+                          </m:e>
+                          <m:sub>
+                            <m:r>
+                              <a:rPr lang="fr-FR" sz="1400" i="1">
+                                <a:latin typeface="Cambria Math" panose="02040503050406030204" pitchFamily="18" charset="0"/>
+                                <a:ea typeface="Cambria" panose="02040503050406030204" pitchFamily="18" charset="0"/>
+                                <a:cs typeface="Times New Roman" panose="02020603050405020304" pitchFamily="18" charset="0"/>
+                              </a:rPr>
+                              <m:t>𝑒𝑥𝑝</m:t>
+                            </m:r>
+                          </m:sub>
+                          <m:sup>
+                            <m:r>
+                              <a:rPr lang="fr-FR" sz="1400" b="0" i="1" smtClean="0">
+                                <a:latin typeface="Cambria Math" panose="02040503050406030204" pitchFamily="18" charset="0"/>
+                                <a:ea typeface="Cambria" panose="02040503050406030204" pitchFamily="18" charset="0"/>
+                                <a:cs typeface="Times New Roman" panose="02020603050405020304" pitchFamily="18" charset="0"/>
+                              </a:rPr>
+                              <m:t>𝑖</m:t>
+                            </m:r>
+                          </m:sup>
+                        </m:sSubSup>
+                      </m:den>
+                    </m:f>
+                  </m:oMath>
+                </a14:m>
+                <a:endParaRPr lang="en-US" sz="1400" i="1" kern="100" dirty="0">
+                  <a:latin typeface="Cambria" panose="02040503050406030204" pitchFamily="18" charset="0"/>
+                  <a:ea typeface="Cambria" panose="02040503050406030204" pitchFamily="18" charset="0"/>
+                  <a:cs typeface="Times New Roman" panose="02020603050405020304" pitchFamily="18" charset="0"/>
+                </a:endParaRPr>
+              </a:p>
+              <a:p>
+                <a:pPr marL="228600">
+                  <a:lnSpc>
+                    <a:spcPct val="107000"/>
+                  </a:lnSpc>
+                  <a:spcAft>
+                    <a:spcPts val="800"/>
+                  </a:spcAft>
+                </a:pPr>
+                <a:r>
+                  <a:rPr lang="en-US" sz="1400" i="1" kern="100" dirty="0">
+                    <a:latin typeface="Cambria" panose="02040503050406030204" pitchFamily="18" charset="0"/>
+                    <a:ea typeface="Cambria" panose="02040503050406030204" pitchFamily="18" charset="0"/>
+                    <a:cs typeface="Times New Roman" panose="02020603050405020304" pitchFamily="18" charset="0"/>
+                  </a:rPr>
+                  <a:t>The theory described in the SCALE 6.3.1 user manual (Section 6.8.4.2) indicates the presence of a diagonal (“E/C”) matrix on both sides of the experimental uncertainty matrix, thereby transforming its terms into experimental uncertainties relative to the calculated response</a:t>
                 </a:r>
                 <a:r>
                   <a:rPr lang="fr-FR" sz="1400" i="1" kern="100" dirty="0">
@@ -25891,7 +25997,7 @@
                     <m:f>
                       <m:fPr>
                         <m:ctrlPr>
-                          <a:rPr lang="fr-FR" b="0" i="1" smtClean="0">
+                          <a:rPr lang="fr-FR" sz="1400" b="0" i="1" smtClean="0">
                             <a:solidFill>
                               <a:schemeClr val="tx1"/>
                             </a:solidFill>
@@ -25905,7 +26011,7 @@
                         <m:sSup>
                           <m:sSupPr>
                             <m:ctrlPr>
-                              <a:rPr lang="fr-FR" b="0" i="1" smtClean="0">
+                              <a:rPr lang="fr-FR" sz="1400" b="0" i="1" smtClean="0">
                                 <a:solidFill>
                                   <a:schemeClr val="tx1"/>
                                 </a:solidFill>
@@ -25919,7 +26025,7 @@
                             <m:sSubSup>
                               <m:sSubSupPr>
                                 <m:ctrlPr>
-                                  <a:rPr lang="fr-FR" b="0" i="1" smtClean="0">
+                                  <a:rPr lang="fr-FR" sz="1400" b="0" i="1" smtClean="0">
                                     <a:solidFill>
                                       <a:schemeClr val="tx1"/>
                                     </a:solidFill>
@@ -25931,7 +26037,7 @@
                               </m:sSubSupPr>
                               <m:e>
                                 <m:r>
-                                  <a:rPr lang="fr-FR" b="0" i="1" smtClean="0">
+                                  <a:rPr lang="fr-FR" sz="1400" b="0" i="1" smtClean="0">
                                     <a:solidFill>
                                       <a:schemeClr val="tx1"/>
                                     </a:solidFill>
@@ -25943,7 +26049,7 @@
                               </m:e>
                               <m:sub>
                                 <m:r>
-                                  <a:rPr lang="fr-FR" b="0" i="1" smtClean="0">
+                                  <a:rPr lang="fr-FR" sz="1400" b="0" i="1" smtClean="0">
                                     <a:solidFill>
                                       <a:schemeClr val="tx1"/>
                                     </a:solidFill>
@@ -25956,7 +26062,7 @@
                               </m:sub>
                               <m:sup>
                                 <m:r>
-                                  <a:rPr lang="fr-FR" b="0" i="1" smtClean="0">
+                                  <a:rPr lang="fr-FR" sz="1400" b="0" i="1" smtClean="0">
                                     <a:solidFill>
                                       <a:schemeClr val="tx1"/>
                                     </a:solidFill>
@@ -25971,7 +26077,7 @@
                           </m:e>
                           <m:sup>
                             <m:r>
-                              <a:rPr lang="fr-FR" b="0" i="1" smtClean="0">
+                              <a:rPr lang="fr-FR" sz="1400" b="0" i="1" smtClean="0">
                                 <a:solidFill>
                                   <a:schemeClr val="tx1"/>
                                 </a:solidFill>
@@ -25988,7 +26094,7 @@
                         <m:sSup>
                           <m:sSupPr>
                             <m:ctrlPr>
-                              <a:rPr lang="fr-FR" b="0" i="1" smtClean="0">
+                              <a:rPr lang="fr-FR" sz="1400" b="0" i="1" smtClean="0">
                                 <a:solidFill>
                                   <a:schemeClr val="tx1"/>
                                 </a:solidFill>
@@ -26002,7 +26108,7 @@
                             <m:sSubSup>
                               <m:sSubSupPr>
                                 <m:ctrlPr>
-                                  <a:rPr lang="fr-FR" b="0" i="1" smtClean="0">
+                                  <a:rPr lang="fr-FR" sz="1400" b="0" i="1" smtClean="0">
                                     <a:solidFill>
                                       <a:schemeClr val="tx1"/>
                                     </a:solidFill>
@@ -26014,7 +26120,7 @@
                               </m:sSubSupPr>
                               <m:e>
                                 <m:r>
-                                  <a:rPr lang="fr-FR" b="0" i="1" smtClean="0">
+                                  <a:rPr lang="fr-FR" sz="1400" b="0" i="1" smtClean="0">
                                     <a:solidFill>
                                       <a:schemeClr val="tx1"/>
                                     </a:solidFill>
@@ -26022,12 +26128,12 @@
                                     <a:ea typeface="Cambria" panose="02040503050406030204" pitchFamily="18" charset="0"/>
                                     <a:cs typeface="Times New Roman" panose="02020603050405020304" pitchFamily="18" charset="0"/>
                                   </a:rPr>
-                                  <m:t>𝑘𝑒𝑓𝑓</m:t>
+                                  <m:t>𝑟𝑒𝑠𝑝</m:t>
                                 </m:r>
                               </m:e>
                               <m:sub>
                                 <m:r>
-                                  <a:rPr lang="fr-FR" b="0" i="1" smtClean="0">
+                                  <a:rPr lang="fr-FR" sz="1400" b="0" i="1" smtClean="0">
                                     <a:solidFill>
                                       <a:schemeClr val="tx1"/>
                                     </a:solidFill>
@@ -26040,7 +26146,7 @@
                               </m:sub>
                               <m:sup>
                                 <m:r>
-                                  <a:rPr lang="fr-FR" b="0" i="1" smtClean="0">
+                                  <a:rPr lang="fr-FR" sz="1400" b="0" i="1" smtClean="0">
                                     <a:solidFill>
                                       <a:schemeClr val="tx1"/>
                                     </a:solidFill>
@@ -26055,7 +26161,7 @@
                           </m:e>
                           <m:sup>
                             <m:r>
-                              <a:rPr lang="fr-FR" b="0" i="1" smtClean="0">
+                              <a:rPr lang="fr-FR" sz="1400" b="0" i="1" smtClean="0">
                                 <a:solidFill>
                                   <a:schemeClr val="tx1"/>
                                 </a:solidFill>
@@ -26072,7 +26178,7 @@
                   </m:oMath>
                 </a14:m>
                 <a:r>
-                  <a:rPr lang="fr-FR" i="1" kern="100" dirty="0">
+                  <a:rPr lang="fr-FR" sz="1400" i="1" kern="100" dirty="0">
                     <a:solidFill>
                       <a:schemeClr val="tx1"/>
                     </a:solidFill>
@@ -26084,7 +26190,7 @@
                   <a:t> </a:t>
                 </a:r>
                 <a:r>
-                  <a:rPr lang="fr-FR" i="1" kern="100" dirty="0">
+                  <a:rPr lang="fr-FR" sz="1400" i="1" kern="100" dirty="0">
                     <a:solidFill>
                       <a:schemeClr val="tx1"/>
                     </a:solidFill>
@@ -26096,7 +26202,7 @@
                   <a:t></a:t>
                 </a:r>
                 <a:r>
-                  <a:rPr lang="fr-FR" i="1" kern="100" dirty="0">
+                  <a:rPr lang="fr-FR" sz="1400" i="1" kern="100" dirty="0">
                     <a:solidFill>
                       <a:schemeClr val="tx1"/>
                     </a:solidFill>
@@ -26112,7 +26218,7 @@
                     <m:f>
                       <m:fPr>
                         <m:ctrlPr>
-                          <a:rPr lang="fr-FR" i="1">
+                          <a:rPr lang="fr-FR" sz="1400" i="1">
                             <a:solidFill>
                               <a:schemeClr val="tx1"/>
                             </a:solidFill>
@@ -26126,7 +26232,7 @@
                         <m:sSup>
                           <m:sSupPr>
                             <m:ctrlPr>
-                              <a:rPr lang="fr-FR" i="1">
+                              <a:rPr lang="fr-FR" sz="1400" i="1">
                                 <a:solidFill>
                                   <a:schemeClr val="tx1"/>
                                 </a:solidFill>
@@ -26140,7 +26246,7 @@
                             <m:sSubSup>
                               <m:sSubSupPr>
                                 <m:ctrlPr>
-                                  <a:rPr lang="fr-FR" i="1">
+                                  <a:rPr lang="fr-FR" sz="1400" i="1">
                                     <a:solidFill>
                                       <a:schemeClr val="tx1"/>
                                     </a:solidFill>
@@ -26152,7 +26258,7 @@
                               </m:sSubSupPr>
                               <m:e>
                                 <m:r>
-                                  <a:rPr lang="fr-FR" i="1">
+                                  <a:rPr lang="fr-FR" sz="1400" i="1">
                                     <a:solidFill>
                                       <a:schemeClr val="tx1"/>
                                     </a:solidFill>
@@ -26164,7 +26270,7 @@
                               </m:e>
                               <m:sub>
                                 <m:r>
-                                  <a:rPr lang="fr-FR" i="1">
+                                  <a:rPr lang="fr-FR" sz="1400" i="1">
                                     <a:solidFill>
                                       <a:schemeClr val="tx1"/>
                                     </a:solidFill>
@@ -26177,7 +26283,7 @@
                               </m:sub>
                               <m:sup>
                                 <m:r>
-                                  <a:rPr lang="fr-FR" i="1">
+                                  <a:rPr lang="fr-FR" sz="1400" i="1">
                                     <a:solidFill>
                                       <a:schemeClr val="tx1"/>
                                     </a:solidFill>
@@ -26192,7 +26298,7 @@
                           </m:e>
                           <m:sup>
                             <m:r>
-                              <a:rPr lang="fr-FR" i="1">
+                              <a:rPr lang="fr-FR" sz="1400" i="1">
                                 <a:solidFill>
                                   <a:schemeClr val="tx1"/>
                                 </a:solidFill>
@@ -26209,7 +26315,7 @@
                         <m:sSup>
                           <m:sSupPr>
                             <m:ctrlPr>
-                              <a:rPr lang="fr-FR" i="1">
+                              <a:rPr lang="fr-FR" sz="1400" i="1">
                                 <a:solidFill>
                                   <a:schemeClr val="tx1"/>
                                 </a:solidFill>
@@ -26223,7 +26329,7 @@
                             <m:sSubSup>
                               <m:sSubSupPr>
                                 <m:ctrlPr>
-                                  <a:rPr lang="fr-FR" i="1">
+                                  <a:rPr lang="fr-FR" sz="1400" i="1">
                                     <a:solidFill>
                                       <a:schemeClr val="tx1"/>
                                     </a:solidFill>
@@ -26235,7 +26341,7 @@
                               </m:sSubSupPr>
                               <m:e>
                                 <m:r>
-                                  <a:rPr lang="fr-FR" i="1">
+                                  <a:rPr lang="fr-FR" sz="1400" b="0" i="1" smtClean="0">
                                     <a:solidFill>
                                       <a:schemeClr val="tx1"/>
                                     </a:solidFill>
@@ -26243,12 +26349,12 @@
                                     <a:ea typeface="Cambria" panose="02040503050406030204" pitchFamily="18" charset="0"/>
                                     <a:cs typeface="Times New Roman" panose="02020603050405020304" pitchFamily="18" charset="0"/>
                                   </a:rPr>
-                                  <m:t>𝑘𝑒𝑓𝑓</m:t>
+                                  <m:t>𝑟𝑒𝑠𝑝</m:t>
                                 </m:r>
                               </m:e>
                               <m:sub>
                                 <m:r>
-                                  <a:rPr lang="fr-FR" b="0" i="1" smtClean="0">
+                                  <a:rPr lang="fr-FR" sz="1400" b="0" i="1" smtClean="0">
                                     <a:solidFill>
                                       <a:schemeClr val="tx1"/>
                                     </a:solidFill>
@@ -26261,7 +26367,7 @@
                               </m:sub>
                               <m:sup>
                                 <m:r>
-                                  <a:rPr lang="fr-FR" i="1">
+                                  <a:rPr lang="fr-FR" sz="1400" i="1">
                                     <a:solidFill>
                                       <a:schemeClr val="tx1"/>
                                     </a:solidFill>
@@ -26276,7 +26382,7 @@
                           </m:e>
                           <m:sup>
                             <m:r>
-                              <a:rPr lang="fr-FR" i="1">
+                              <a:rPr lang="fr-FR" sz="1400" i="1">
                                 <a:solidFill>
                                   <a:schemeClr val="tx1"/>
                                 </a:solidFill>
@@ -26305,7 +26411,7 @@
             </p:txBody>
           </p:sp>
         </mc:Choice>
-        <mc:Fallback xmlns="">
+        <mc:Fallback>
           <p:sp>
             <p:nvSpPr>
               <p:cNvPr id="9" name="TextBox 6">
@@ -26322,8 +26428,8 @@
             </p:nvSpPr>
             <p:spPr>
               <a:xfrm>
-                <a:off x="444689" y="4741354"/>
-                <a:ext cx="11302621" cy="1569721"/>
+                <a:off x="444689" y="4699677"/>
+                <a:ext cx="11302621" cy="2067516"/>
               </a:xfrm>
               <a:prstGeom prst="roundRect">
                 <a:avLst/>
@@ -26347,7 +26453,7 @@
               <a:lstStyle/>
               <a:p>
                 <a:r>
-                  <a:rPr lang="en-US">
+                  <a:rPr lang="fr-FR">
                     <a:noFill/>
                   </a:rPr>
                   <a:t> </a:t>
@@ -26388,7 +26494,7 @@
         </p:blipFill>
         <p:spPr>
           <a:xfrm>
-            <a:off x="215710" y="4393439"/>
+            <a:off x="206379" y="4253475"/>
             <a:ext cx="647700" cy="647700"/>
           </a:xfrm>
           <a:prstGeom prst="rect">
@@ -26579,7 +26685,7 @@
         <p:spPr>
           <a:xfrm>
             <a:off x="3348502" y="86002"/>
-            <a:ext cx="4746877" cy="523220"/>
+            <a:ext cx="5377113" cy="523220"/>
           </a:xfrm>
           <a:prstGeom prst="rect">
             <a:avLst/>
@@ -26630,15 +26736,15 @@
                 <a:ea typeface="Cambria" panose="02040503050406030204" pitchFamily="18" charset="0"/>
                 <a:cs typeface="Times New Roman" panose="02020603050405020304" pitchFamily="18" charset="0"/>
               </a:rPr>
-              <a:t> k</a:t>
+              <a:t> </a:t>
             </a:r>
             <a:r>
-              <a:rPr lang="fr-FR" baseline="-25000" dirty="0">
+              <a:rPr lang="fr-FR" dirty="0" err="1">
                 <a:latin typeface="Cambria" panose="02040503050406030204" pitchFamily="18" charset="0"/>
                 <a:ea typeface="Cambria" panose="02040503050406030204" pitchFamily="18" charset="0"/>
                 <a:cs typeface="Times New Roman" panose="02020603050405020304" pitchFamily="18" charset="0"/>
               </a:rPr>
-              <a:t>eff</a:t>
+              <a:t>response</a:t>
             </a:r>
             <a:r>
               <a:rPr lang="fr-FR" dirty="0">
@@ -28722,37 +28828,14 @@
                           </a:rPr>
                           <m:t>∆</m:t>
                         </m:r>
-                        <m:sSub>
-                          <m:sSubPr>
-                            <m:ctrlPr>
-                              <a:rPr lang="fr-FR" sz="1600" i="1" kern="100">
-                                <a:latin typeface="Cambria Math" panose="02040503050406030204" pitchFamily="18" charset="0"/>
-                                <a:ea typeface="Times New Roman" panose="02020603050405020304" pitchFamily="18" charset="0"/>
-                                <a:cs typeface="Times New Roman" panose="02020603050405020304" pitchFamily="18" charset="0"/>
-                              </a:rPr>
-                            </m:ctrlPr>
-                          </m:sSubPr>
-                          <m:e>
-                            <m:r>
-                              <a:rPr lang="fr-FR" sz="1600" i="1" kern="100">
-                                <a:latin typeface="Cambria Math" panose="02040503050406030204" pitchFamily="18" charset="0"/>
-                                <a:ea typeface="Times New Roman" panose="02020603050405020304" pitchFamily="18" charset="0"/>
-                                <a:cs typeface="Times New Roman" panose="02020603050405020304" pitchFamily="18" charset="0"/>
-                              </a:rPr>
-                              <m:t>𝑘</m:t>
-                            </m:r>
-                          </m:e>
-                          <m:sub>
-                            <m:r>
-                              <a:rPr lang="fr-FR" sz="1600" i="1" kern="100">
-                                <a:latin typeface="Cambria Math" panose="02040503050406030204" pitchFamily="18" charset="0"/>
-                                <a:ea typeface="Times New Roman" panose="02020603050405020304" pitchFamily="18" charset="0"/>
-                                <a:cs typeface="Times New Roman" panose="02020603050405020304" pitchFamily="18" charset="0"/>
-                              </a:rPr>
-                              <m:t>𝑒𝑓𝑓</m:t>
-                            </m:r>
-                          </m:sub>
-                        </m:sSub>
+                        <m:r>
+                          <a:rPr lang="fr-FR" sz="1600" b="0" i="1" kern="100" smtClean="0">
+                            <a:latin typeface="Cambria Math" panose="02040503050406030204" pitchFamily="18" charset="0"/>
+                            <a:ea typeface="Times New Roman" panose="02020603050405020304" pitchFamily="18" charset="0"/>
+                            <a:cs typeface="Times New Roman" panose="02020603050405020304" pitchFamily="18" charset="0"/>
+                          </a:rPr>
+                          <m:t>𝑟𝑒𝑠𝑝</m:t>
+                        </m:r>
                       </m:num>
                       <m:den>
                         <m:r>
@@ -28812,15 +28895,15 @@
                     <a:ea typeface="Cambria" panose="02040503050406030204" pitchFamily="18" charset="0"/>
                     <a:cs typeface="Times New Roman" panose="02020603050405020304" pitchFamily="18" charset="0"/>
                   </a:rPr>
-                  <a:t>: variation of k</a:t>
+                  <a:t>: variation of </a:t>
                 </a:r>
                 <a:r>
-                  <a:rPr lang="fr-FR" sz="1600" i="1" kern="100" baseline="-25000" dirty="0">
+                  <a:rPr lang="fr-FR" sz="1600" i="1" kern="100" dirty="0" err="1">
                     <a:latin typeface="Cambria" panose="02040503050406030204" pitchFamily="18" charset="0"/>
                     <a:ea typeface="Cambria" panose="02040503050406030204" pitchFamily="18" charset="0"/>
                     <a:cs typeface="Times New Roman" panose="02020603050405020304" pitchFamily="18" charset="0"/>
                   </a:rPr>
-                  <a:t>eff</a:t>
+                  <a:t>response</a:t>
                 </a:r>
                 <a:r>
                   <a:rPr lang="fr-FR" sz="1600" i="1" kern="100" dirty="0">
@@ -28828,15 +28911,15 @@
                     <a:ea typeface="Cambria" panose="02040503050406030204" pitchFamily="18" charset="0"/>
                     <a:cs typeface="Times New Roman" panose="02020603050405020304" pitchFamily="18" charset="0"/>
                   </a:rPr>
-                  <a:t> (∆k</a:t>
+                  <a:t> (∆</a:t>
                 </a:r>
                 <a:r>
-                  <a:rPr lang="fr-FR" sz="1600" i="1" kern="100" baseline="-25000" dirty="0">
+                  <a:rPr lang="fr-FR" sz="1600" i="1" kern="100" dirty="0" err="1">
                     <a:latin typeface="Cambria" panose="02040503050406030204" pitchFamily="18" charset="0"/>
                     <a:ea typeface="Cambria" panose="02040503050406030204" pitchFamily="18" charset="0"/>
                     <a:cs typeface="Times New Roman" panose="02020603050405020304" pitchFamily="18" charset="0"/>
                   </a:rPr>
-                  <a:t>eff</a:t>
+                  <a:t>resp</a:t>
                 </a:r>
                 <a:r>
                   <a:rPr lang="fr-FR" sz="1600" i="1" kern="100" dirty="0">
@@ -29169,7 +29252,7 @@
               <a:blipFill>
                 <a:blip r:embed="rId3"/>
                 <a:stretch>
-                  <a:fillRect b="-5848"/>
+                  <a:fillRect b="-4094"/>
                 </a:stretch>
               </a:blipFill>
               <a:ln w="12700">
@@ -29183,7 +29266,7 @@
               <a:lstStyle/>
               <a:p>
                 <a:r>
-                  <a:rPr lang="en-US">
+                  <a:rPr lang="fr-FR">
                     <a:noFill/>
                   </a:rPr>
                   <a:t> </a:t>

</xml_diff>